<commit_message>
Energypedia: zasady języka i rzetelności, półpauza zamiast długiego myślnika we wszystkich materiałach
Co-Authored-By: Claude Opus 5.5 <noreply@anthropic.com>
Claude-Session: https://claude.ai/code/session_01Rv6z9UcN5eHj71s4nzprHT
</commit_message>
<xml_diff>
--- a/docs/energypedia/brand/canva/Energypedia_Canva_post_1080x1350.pptx
+++ b/docs/energypedia/brand/canva/Energypedia_Canva_post_1080x1350.pptx
@@ -1307,7 +1307,7 @@
                 <a:ea typeface="Space Grotesk" pitchFamily="34" charset="-122"/>
                 <a:cs typeface="Space Grotesk" pitchFamily="34" charset="-120"/>
               </a:rPr>
-              <a:t>[Najważniejsza teza z wydarzenia — do 70 znaków]</a:t>
+              <a:t>[Najważniejsza teza z wydarzenia – do 70 znaków]</a:t>
             </a:r>
             <a:endParaRPr lang="en-US" sz="3750" dirty="0"/>
           </a:p>
@@ -1588,7 +1588,7 @@
                 <a:ea typeface="Space Grotesk" pitchFamily="34" charset="-122"/>
                 <a:cs typeface="Space Grotesk" pitchFamily="34" charset="-120"/>
               </a:rPr>
-              <a:t>[Tytuł wpisu — do 70 znaków]</a:t>
+              <a:t>[Tytuł wpisu – do 70 znaków]</a:t>
             </a:r>
             <a:endParaRPr lang="en-US" sz="3750" dirty="0"/>
           </a:p>
@@ -1984,7 +1984,7 @@
                 <a:ea typeface="Space Grotesk" pitchFamily="34" charset="-122"/>
                 <a:cs typeface="Space Grotesk" pitchFamily="34" charset="-120"/>
               </a:rPr>
-              <a:t>„[Najmocniejsze zdanie z rozmowy — do 90 znaków]”</a:t>
+              <a:t>„[Najmocniejsze zdanie z rozmowy – do 90 znaków]”</a:t>
             </a:r>
             <a:endParaRPr lang="en-US" sz="4200" dirty="0"/>
           </a:p>

</xml_diff>